<commit_message>
add new logo blocks to templates
</commit_message>
<xml_diff>
--- a/_extensions/aagi/pptx/template.pptx
+++ b/_extensions/aagi/pptx/template.pptx
@@ -198,7 +198,7 @@
           <a:p>
             <a:fld id="{0FAF8F18-604A-4237-961E-CD67640E1CD4}" type="datetimeFigureOut">
               <a:rPr lang="en-AU" smtClean="0"/>
-              <a:t>19/11/2025</a:t>
+              <a:t>26/3/2026</a:t>
             </a:fld>
             <a:endParaRPr lang="en-AU"/>
           </a:p>
@@ -534,21 +534,14 @@
           <p:nvPr userDrawn="1"/>
         </p:nvPicPr>
         <p:blipFill>
-          <a:blip r:embed="rId3">
-            <a:extLst>
-              <a:ext uri="{28A0092B-C50C-407E-A947-70E740481C1C}">
-                <a14:useLocalDpi xmlns:a14="http://schemas.microsoft.com/office/drawing/2010/main" val="0"/>
-              </a:ext>
-            </a:extLst>
-          </a:blip>
-          <a:stretch>
-            <a:fillRect/>
-          </a:stretch>
+          <a:blip r:embed="rId3"/>
+          <a:srcRect/>
+          <a:stretch/>
         </p:blipFill>
         <p:spPr>
           <a:xfrm>
-            <a:off x="0" y="5807075"/>
-            <a:ext cx="12192000" cy="784225"/>
+            <a:off x="1422659" y="5807075"/>
+            <a:ext cx="9346681" cy="784225"/>
           </a:xfrm>
           <a:prstGeom prst="rect">
             <a:avLst/>

</xml_diff>

<commit_message>
update ppt template to match Pandoc expectations
</commit_message>
<xml_diff>
--- a/_extensions/aagi/pptx/template.pptx
+++ b/_extensions/aagi/pptx/template.pptx
@@ -198,7 +198,7 @@
           <a:p>
             <a:fld id="{0FAF8F18-604A-4237-961E-CD67640E1CD4}" type="datetimeFigureOut">
               <a:rPr lang="en-AU" smtClean="0"/>
-              <a:t>26/3/2026</a:t>
+              <a:t>27/3/2026</a:t>
             </a:fld>
             <a:endParaRPr lang="en-AU"/>
           </a:p>
@@ -1634,6 +1634,398 @@
 </file>
 
 <file path=ppt/slideLayouts/slideLayout4.xml><?xml version="1.0" encoding="utf-8"?>
+<p:sldLayout xmlns:a="http://schemas.openxmlformats.org/drawingml/2006/main" xmlns:r="http://schemas.openxmlformats.org/officeDocument/2006/relationships" xmlns:p="http://schemas.openxmlformats.org/presentationml/2006/main" type="twoObj" preserve="1">
+  <p:cSld name="Comparison">
+    <p:spTree>
+      <p:nvGrpSpPr>
+        <p:cNvPr id="1" name=""/>
+        <p:cNvGrpSpPr/>
+        <p:nvPr/>
+      </p:nvGrpSpPr>
+      <p:grpSpPr>
+        <a:xfrm>
+          <a:off x="0" y="0"/>
+          <a:ext cx="0" cy="0"/>
+          <a:chOff x="0" y="0"/>
+          <a:chExt cx="0" cy="0"/>
+        </a:xfrm>
+      </p:grpSpPr>
+      <p:pic>
+        <p:nvPicPr>
+          <p:cNvPr id="15" name="Picture 14" descr="A logo with text on it&#10;&#10;Description automatically generated">
+            <a:extLst>
+              <a:ext uri="{FF2B5EF4-FFF2-40B4-BE49-F238E27FC236}">
+                <a16:creationId xmlns:a16="http://schemas.microsoft.com/office/drawing/2014/main" id="{1A00B997-B0F6-7E6F-9058-2406C51BDAB8}"/>
+              </a:ext>
+            </a:extLst>
+          </p:cNvPr>
+          <p:cNvPicPr>
+            <a:picLocks noChangeAspect="1"/>
+          </p:cNvPicPr>
+          <p:nvPr userDrawn="1"/>
+        </p:nvPicPr>
+        <p:blipFill>
+          <a:blip r:embed="rId2">
+            <a:extLst>
+              <a:ext uri="{28A0092B-C50C-407E-A947-70E740481C1C}">
+                <a14:useLocalDpi xmlns:a14="http://schemas.microsoft.com/office/drawing/2010/main" val="0"/>
+              </a:ext>
+            </a:extLst>
+          </a:blip>
+          <a:stretch>
+            <a:fillRect/>
+          </a:stretch>
+        </p:blipFill>
+        <p:spPr>
+          <a:xfrm>
+            <a:off x="10191750" y="168275"/>
+            <a:ext cx="1768474" cy="844364"/>
+          </a:xfrm>
+          <a:prstGeom prst="rect">
+            <a:avLst/>
+          </a:prstGeom>
+        </p:spPr>
+      </p:pic>
+      <p:sp>
+        <p:nvSpPr>
+          <p:cNvPr id="9" name="Rectangle 8">
+            <a:extLst>
+              <a:ext uri="{FF2B5EF4-FFF2-40B4-BE49-F238E27FC236}">
+                <a16:creationId xmlns:a16="http://schemas.microsoft.com/office/drawing/2014/main" id="{54FE6354-61F0-3E61-AB8B-50117C047A52}"/>
+              </a:ext>
+            </a:extLst>
+          </p:cNvPr>
+          <p:cNvSpPr/>
+          <p:nvPr userDrawn="1"/>
+        </p:nvSpPr>
+        <p:spPr>
+          <a:xfrm>
+            <a:off x="0" y="6629400"/>
+            <a:ext cx="12192000" cy="228600"/>
+          </a:xfrm>
+          <a:prstGeom prst="rect">
+            <a:avLst/>
+          </a:prstGeom>
+          <a:solidFill>
+            <a:srgbClr val="00808B"/>
+          </a:solidFill>
+          <a:ln>
+            <a:noFill/>
+          </a:ln>
+        </p:spPr>
+        <p:style>
+          <a:lnRef idx="2">
+            <a:schemeClr val="accent1">
+              <a:shade val="15000"/>
+            </a:schemeClr>
+          </a:lnRef>
+          <a:fillRef idx="1">
+            <a:schemeClr val="accent1"/>
+          </a:fillRef>
+          <a:effectRef idx="0">
+            <a:schemeClr val="accent1"/>
+          </a:effectRef>
+          <a:fontRef idx="minor">
+            <a:schemeClr val="lt1"/>
+          </a:fontRef>
+        </p:style>
+        <p:txBody>
+          <a:bodyPr rtlCol="0" anchor="ctr"/>
+          <a:lstStyle/>
+          <a:p>
+            <a:pPr algn="ctr"/>
+            <a:endParaRPr lang="en-AU"/>
+          </a:p>
+        </p:txBody>
+      </p:sp>
+      <p:sp>
+        <p:nvSpPr>
+          <p:cNvPr id="10" name="Date Placeholder 3">
+            <a:extLst>
+              <a:ext uri="{FF2B5EF4-FFF2-40B4-BE49-F238E27FC236}">
+                <a16:creationId xmlns:a16="http://schemas.microsoft.com/office/drawing/2014/main" id="{2D81AA63-9033-31BC-9C81-78FF676D25BC}"/>
+              </a:ext>
+            </a:extLst>
+          </p:cNvPr>
+          <p:cNvSpPr>
+            <a:spLocks noGrp="1"/>
+          </p:cNvSpPr>
+          <p:nvPr>
+            <p:ph type="dt" sz="half" idx="10"/>
+          </p:nvPr>
+        </p:nvSpPr>
+        <p:spPr>
+          <a:xfrm>
+            <a:off x="0" y="6629400"/>
+            <a:ext cx="2743200" cy="228600"/>
+          </a:xfrm>
+        </p:spPr>
+        <p:txBody>
+          <a:bodyPr/>
+          <a:lstStyle>
+            <a:lvl1pPr>
+              <a:defRPr>
+                <a:solidFill>
+                  <a:schemeClr val="bg1"/>
+                </a:solidFill>
+              </a:defRPr>
+            </a:lvl1pPr>
+          </a:lstStyle>
+          <a:p>
+            <a:endParaRPr lang="en-AU" dirty="0"/>
+          </a:p>
+        </p:txBody>
+      </p:sp>
+      <p:sp>
+        <p:nvSpPr>
+          <p:cNvPr id="11" name="Footer Placeholder 4">
+            <a:extLst>
+              <a:ext uri="{FF2B5EF4-FFF2-40B4-BE49-F238E27FC236}">
+                <a16:creationId xmlns:a16="http://schemas.microsoft.com/office/drawing/2014/main" id="{1E9293D2-CBEA-CEFE-A587-45CE55F56E69}"/>
+              </a:ext>
+            </a:extLst>
+          </p:cNvPr>
+          <p:cNvSpPr>
+            <a:spLocks noGrp="1"/>
+          </p:cNvSpPr>
+          <p:nvPr>
+            <p:ph type="ftr" sz="quarter" idx="11"/>
+          </p:nvPr>
+        </p:nvSpPr>
+        <p:spPr>
+          <a:xfrm>
+            <a:off x="4038600" y="6629400"/>
+            <a:ext cx="4114800" cy="228600"/>
+          </a:xfrm>
+        </p:spPr>
+        <p:txBody>
+          <a:bodyPr/>
+          <a:lstStyle>
+            <a:lvl1pPr>
+              <a:defRPr>
+                <a:solidFill>
+                  <a:schemeClr val="bg1"/>
+                </a:solidFill>
+              </a:defRPr>
+            </a:lvl1pPr>
+          </a:lstStyle>
+          <a:p>
+            <a:endParaRPr lang="en-AU" dirty="0"/>
+          </a:p>
+        </p:txBody>
+      </p:sp>
+      <p:sp>
+        <p:nvSpPr>
+          <p:cNvPr id="12" name="Slide Number Placeholder 5">
+            <a:extLst>
+              <a:ext uri="{FF2B5EF4-FFF2-40B4-BE49-F238E27FC236}">
+                <a16:creationId xmlns:a16="http://schemas.microsoft.com/office/drawing/2014/main" id="{1107C7A2-0AA4-0E4C-2A42-86BC701B550A}"/>
+              </a:ext>
+            </a:extLst>
+          </p:cNvPr>
+          <p:cNvSpPr>
+            <a:spLocks noGrp="1"/>
+          </p:cNvSpPr>
+          <p:nvPr>
+            <p:ph type="sldNum" sz="quarter" idx="12"/>
+          </p:nvPr>
+        </p:nvSpPr>
+        <p:spPr>
+          <a:xfrm>
+            <a:off x="9448800" y="6629400"/>
+            <a:ext cx="2743200" cy="228600"/>
+          </a:xfrm>
+        </p:spPr>
+        <p:txBody>
+          <a:bodyPr/>
+          <a:lstStyle>
+            <a:lvl1pPr>
+              <a:defRPr>
+                <a:solidFill>
+                  <a:schemeClr val="bg1"/>
+                </a:solidFill>
+              </a:defRPr>
+            </a:lvl1pPr>
+          </a:lstStyle>
+          <a:p>
+            <a:fld id="{D8E684C7-7750-4CD9-985D-E80E6D7E3A96}" type="slidenum">
+              <a:rPr lang="en-AU" smtClean="0"/>
+              <a:pPr/>
+              <a:t>‹#›</a:t>
+            </a:fld>
+            <a:endParaRPr lang="en-AU" dirty="0"/>
+          </a:p>
+        </p:txBody>
+      </p:sp>
+      <p:sp>
+        <p:nvSpPr>
+          <p:cNvPr id="2" name="Title 1">
+            <a:extLst>
+              <a:ext uri="{FF2B5EF4-FFF2-40B4-BE49-F238E27FC236}">
+                <a16:creationId xmlns:a16="http://schemas.microsoft.com/office/drawing/2014/main" id="{EC0876AE-06E6-AC69-E8C6-8F887ABD771B}"/>
+              </a:ext>
+            </a:extLst>
+          </p:cNvPr>
+          <p:cNvSpPr>
+            <a:spLocks noGrp="1"/>
+          </p:cNvSpPr>
+          <p:nvPr>
+            <p:ph type="title"/>
+          </p:nvPr>
+        </p:nvSpPr>
+        <p:spPr/>
+        <p:txBody>
+          <a:bodyPr/>
+          <a:lstStyle/>
+          <a:p>
+            <a:r>
+              <a:rPr lang="en-US"/>
+              <a:t>Click to edit Master title style</a:t>
+            </a:r>
+            <a:endParaRPr lang="en-AU"/>
+          </a:p>
+        </p:txBody>
+      </p:sp>
+      <p:sp>
+        <p:nvSpPr>
+          <p:cNvPr id="3" name="Content Placeholder 2">
+            <a:extLst>
+              <a:ext uri="{FF2B5EF4-FFF2-40B4-BE49-F238E27FC236}">
+                <a16:creationId xmlns:a16="http://schemas.microsoft.com/office/drawing/2014/main" id="{16303A8B-C1D7-77DB-1CD5-8945DE1AFD3D}"/>
+              </a:ext>
+            </a:extLst>
+          </p:cNvPr>
+          <p:cNvSpPr>
+            <a:spLocks noGrp="1"/>
+          </p:cNvSpPr>
+          <p:nvPr>
+            <p:ph sz="half" idx="1"/>
+          </p:nvPr>
+        </p:nvSpPr>
+        <p:spPr>
+          <a:xfrm>
+            <a:off x="86259" y="1012639"/>
+            <a:ext cx="5933541" cy="5544401"/>
+          </a:xfrm>
+        </p:spPr>
+        <p:txBody>
+          <a:bodyPr/>
+          <a:lstStyle/>
+          <a:p>
+            <a:pPr lvl="0"/>
+            <a:r>
+              <a:rPr lang="en-US"/>
+              <a:t>Click to edit Master text styles</a:t>
+            </a:r>
+          </a:p>
+          <a:p>
+            <a:pPr lvl="1"/>
+            <a:r>
+              <a:rPr lang="en-US"/>
+              <a:t>Second level</a:t>
+            </a:r>
+          </a:p>
+          <a:p>
+            <a:pPr lvl="2"/>
+            <a:r>
+              <a:rPr lang="en-US"/>
+              <a:t>Third level</a:t>
+            </a:r>
+          </a:p>
+          <a:p>
+            <a:pPr lvl="3"/>
+            <a:r>
+              <a:rPr lang="en-US"/>
+              <a:t>Fourth level</a:t>
+            </a:r>
+          </a:p>
+          <a:p>
+            <a:pPr lvl="4"/>
+            <a:r>
+              <a:rPr lang="en-US"/>
+              <a:t>Fifth level</a:t>
+            </a:r>
+            <a:endParaRPr lang="en-AU" dirty="0"/>
+          </a:p>
+        </p:txBody>
+      </p:sp>
+      <p:sp>
+        <p:nvSpPr>
+          <p:cNvPr id="4" name="Content Placeholder 3">
+            <a:extLst>
+              <a:ext uri="{FF2B5EF4-FFF2-40B4-BE49-F238E27FC236}">
+                <a16:creationId xmlns:a16="http://schemas.microsoft.com/office/drawing/2014/main" id="{4B82A3C7-C689-5D87-80B7-75280C0789FF}"/>
+              </a:ext>
+            </a:extLst>
+          </p:cNvPr>
+          <p:cNvSpPr>
+            <a:spLocks noGrp="1"/>
+          </p:cNvSpPr>
+          <p:nvPr>
+            <p:ph sz="half" idx="2"/>
+          </p:nvPr>
+        </p:nvSpPr>
+        <p:spPr>
+          <a:xfrm>
+            <a:off x="6172201" y="1012639"/>
+            <a:ext cx="5933539" cy="5544400"/>
+          </a:xfrm>
+        </p:spPr>
+        <p:txBody>
+          <a:bodyPr/>
+          <a:lstStyle/>
+          <a:p>
+            <a:pPr lvl="0"/>
+            <a:r>
+              <a:rPr lang="en-US"/>
+              <a:t>Click to edit Master text styles</a:t>
+            </a:r>
+          </a:p>
+          <a:p>
+            <a:pPr lvl="1"/>
+            <a:r>
+              <a:rPr lang="en-US"/>
+              <a:t>Second level</a:t>
+            </a:r>
+          </a:p>
+          <a:p>
+            <a:pPr lvl="2"/>
+            <a:r>
+              <a:rPr lang="en-US"/>
+              <a:t>Third level</a:t>
+            </a:r>
+          </a:p>
+          <a:p>
+            <a:pPr lvl="3"/>
+            <a:r>
+              <a:rPr lang="en-US"/>
+              <a:t>Fourth level</a:t>
+            </a:r>
+          </a:p>
+          <a:p>
+            <a:pPr lvl="4"/>
+            <a:r>
+              <a:rPr lang="en-US"/>
+              <a:t>Fifth level</a:t>
+            </a:r>
+            <a:endParaRPr lang="en-AU" dirty="0"/>
+          </a:p>
+        </p:txBody>
+      </p:sp>
+    </p:spTree>
+    <p:extLst>
+      <p:ext uri="{BB962C8B-B14F-4D97-AF65-F5344CB8AC3E}">
+        <p14:creationId xmlns:p14="http://schemas.microsoft.com/office/powerpoint/2010/main" val="4120092074"/>
+      </p:ext>
+    </p:extLst>
+  </p:cSld>
+  <p:clrMapOvr>
+    <a:masterClrMapping/>
+  </p:clrMapOvr>
+</p:sldLayout>
+</file>
+
+<file path=ppt/slideLayouts/slideLayout5.xml><?xml version="1.0" encoding="utf-8"?>
 <p:sldLayout xmlns:a="http://schemas.openxmlformats.org/drawingml/2006/main" xmlns:r="http://schemas.openxmlformats.org/officeDocument/2006/relationships" xmlns:p="http://schemas.openxmlformats.org/presentationml/2006/main" type="titleOnly" preserve="1">
   <p:cSld name="Title Only">
     <p:spTree>
@@ -1899,7 +2291,273 @@
 </p:sldLayout>
 </file>
 
-<file path=ppt/slideLayouts/slideLayout5.xml><?xml version="1.0" encoding="utf-8"?>
+<file path=ppt/slideLayouts/slideLayout6.xml><?xml version="1.0" encoding="utf-8"?>
+<p:sldLayout xmlns:a="http://schemas.openxmlformats.org/drawingml/2006/main" xmlns:r="http://schemas.openxmlformats.org/officeDocument/2006/relationships" xmlns:p="http://schemas.openxmlformats.org/presentationml/2006/main" type="titleOnly" preserve="1">
+  <p:cSld name="Section Header">
+    <p:spTree>
+      <p:nvGrpSpPr>
+        <p:cNvPr id="1" name=""/>
+        <p:cNvGrpSpPr/>
+        <p:nvPr/>
+      </p:nvGrpSpPr>
+      <p:grpSpPr>
+        <a:xfrm>
+          <a:off x="0" y="0"/>
+          <a:ext cx="0" cy="0"/>
+          <a:chOff x="0" y="0"/>
+          <a:chExt cx="0" cy="0"/>
+        </a:xfrm>
+      </p:grpSpPr>
+      <p:pic>
+        <p:nvPicPr>
+          <p:cNvPr id="13" name="Picture 12" descr="A logo with text on it&#10;&#10;Description automatically generated">
+            <a:extLst>
+              <a:ext uri="{FF2B5EF4-FFF2-40B4-BE49-F238E27FC236}">
+                <a16:creationId xmlns:a16="http://schemas.microsoft.com/office/drawing/2014/main" id="{9027D8AF-06AD-8F11-7B98-75448F1EDB8F}"/>
+              </a:ext>
+            </a:extLst>
+          </p:cNvPr>
+          <p:cNvPicPr>
+            <a:picLocks noChangeAspect="1"/>
+          </p:cNvPicPr>
+          <p:nvPr userDrawn="1"/>
+        </p:nvPicPr>
+        <p:blipFill>
+          <a:blip r:embed="rId2">
+            <a:extLst>
+              <a:ext uri="{28A0092B-C50C-407E-A947-70E740481C1C}">
+                <a14:useLocalDpi xmlns:a14="http://schemas.microsoft.com/office/drawing/2010/main" val="0"/>
+              </a:ext>
+            </a:extLst>
+          </a:blip>
+          <a:stretch>
+            <a:fillRect/>
+          </a:stretch>
+        </p:blipFill>
+        <p:spPr>
+          <a:xfrm>
+            <a:off x="10191750" y="168275"/>
+            <a:ext cx="1768474" cy="844364"/>
+          </a:xfrm>
+          <a:prstGeom prst="rect">
+            <a:avLst/>
+          </a:prstGeom>
+        </p:spPr>
+      </p:pic>
+      <p:sp>
+        <p:nvSpPr>
+          <p:cNvPr id="7" name="Rectangle 6">
+            <a:extLst>
+              <a:ext uri="{FF2B5EF4-FFF2-40B4-BE49-F238E27FC236}">
+                <a16:creationId xmlns:a16="http://schemas.microsoft.com/office/drawing/2014/main" id="{D0AE9F78-3054-B11E-C77D-567108A5DD9C}"/>
+              </a:ext>
+            </a:extLst>
+          </p:cNvPr>
+          <p:cNvSpPr/>
+          <p:nvPr userDrawn="1"/>
+        </p:nvSpPr>
+        <p:spPr>
+          <a:xfrm>
+            <a:off x="0" y="6629400"/>
+            <a:ext cx="12192000" cy="228600"/>
+          </a:xfrm>
+          <a:prstGeom prst="rect">
+            <a:avLst/>
+          </a:prstGeom>
+          <a:solidFill>
+            <a:srgbClr val="00808B"/>
+          </a:solidFill>
+          <a:ln>
+            <a:noFill/>
+          </a:ln>
+        </p:spPr>
+        <p:style>
+          <a:lnRef idx="2">
+            <a:schemeClr val="accent1">
+              <a:shade val="15000"/>
+            </a:schemeClr>
+          </a:lnRef>
+          <a:fillRef idx="1">
+            <a:schemeClr val="accent1"/>
+          </a:fillRef>
+          <a:effectRef idx="0">
+            <a:schemeClr val="accent1"/>
+          </a:effectRef>
+          <a:fontRef idx="minor">
+            <a:schemeClr val="lt1"/>
+          </a:fontRef>
+        </p:style>
+        <p:txBody>
+          <a:bodyPr rtlCol="0" anchor="ctr"/>
+          <a:lstStyle/>
+          <a:p>
+            <a:pPr algn="ctr"/>
+            <a:endParaRPr lang="en-AU"/>
+          </a:p>
+        </p:txBody>
+      </p:sp>
+      <p:sp>
+        <p:nvSpPr>
+          <p:cNvPr id="8" name="Date Placeholder 3">
+            <a:extLst>
+              <a:ext uri="{FF2B5EF4-FFF2-40B4-BE49-F238E27FC236}">
+                <a16:creationId xmlns:a16="http://schemas.microsoft.com/office/drawing/2014/main" id="{9AEC9304-26FC-2D7B-148B-0E0B53AD9B0F}"/>
+              </a:ext>
+            </a:extLst>
+          </p:cNvPr>
+          <p:cNvSpPr>
+            <a:spLocks noGrp="1"/>
+          </p:cNvSpPr>
+          <p:nvPr>
+            <p:ph type="dt" sz="half" idx="10"/>
+          </p:nvPr>
+        </p:nvSpPr>
+        <p:spPr>
+          <a:xfrm>
+            <a:off x="0" y="6629400"/>
+            <a:ext cx="2743200" cy="228600"/>
+          </a:xfrm>
+        </p:spPr>
+        <p:txBody>
+          <a:bodyPr/>
+          <a:lstStyle>
+            <a:lvl1pPr>
+              <a:defRPr>
+                <a:solidFill>
+                  <a:schemeClr val="bg1"/>
+                </a:solidFill>
+              </a:defRPr>
+            </a:lvl1pPr>
+          </a:lstStyle>
+          <a:p>
+            <a:endParaRPr lang="en-AU" dirty="0"/>
+          </a:p>
+        </p:txBody>
+      </p:sp>
+      <p:sp>
+        <p:nvSpPr>
+          <p:cNvPr id="9" name="Footer Placeholder 4">
+            <a:extLst>
+              <a:ext uri="{FF2B5EF4-FFF2-40B4-BE49-F238E27FC236}">
+                <a16:creationId xmlns:a16="http://schemas.microsoft.com/office/drawing/2014/main" id="{D05A145D-6199-1B87-B591-82BE4FE5432E}"/>
+              </a:ext>
+            </a:extLst>
+          </p:cNvPr>
+          <p:cNvSpPr>
+            <a:spLocks noGrp="1"/>
+          </p:cNvSpPr>
+          <p:nvPr>
+            <p:ph type="ftr" sz="quarter" idx="11"/>
+          </p:nvPr>
+        </p:nvSpPr>
+        <p:spPr>
+          <a:xfrm>
+            <a:off x="4038600" y="6629400"/>
+            <a:ext cx="4114800" cy="228600"/>
+          </a:xfrm>
+        </p:spPr>
+        <p:txBody>
+          <a:bodyPr/>
+          <a:lstStyle>
+            <a:lvl1pPr>
+              <a:defRPr>
+                <a:solidFill>
+                  <a:schemeClr val="bg1"/>
+                </a:solidFill>
+              </a:defRPr>
+            </a:lvl1pPr>
+          </a:lstStyle>
+          <a:p>
+            <a:endParaRPr lang="en-AU" dirty="0"/>
+          </a:p>
+        </p:txBody>
+      </p:sp>
+      <p:sp>
+        <p:nvSpPr>
+          <p:cNvPr id="10" name="Slide Number Placeholder 5">
+            <a:extLst>
+              <a:ext uri="{FF2B5EF4-FFF2-40B4-BE49-F238E27FC236}">
+                <a16:creationId xmlns:a16="http://schemas.microsoft.com/office/drawing/2014/main" id="{EEA5DCDC-1F9F-5610-65F1-2885BB40652E}"/>
+              </a:ext>
+            </a:extLst>
+          </p:cNvPr>
+          <p:cNvSpPr>
+            <a:spLocks noGrp="1"/>
+          </p:cNvSpPr>
+          <p:nvPr>
+            <p:ph type="sldNum" sz="quarter" idx="12"/>
+          </p:nvPr>
+        </p:nvSpPr>
+        <p:spPr>
+          <a:xfrm>
+            <a:off x="9448800" y="6629400"/>
+            <a:ext cx="2743200" cy="228600"/>
+          </a:xfrm>
+        </p:spPr>
+        <p:txBody>
+          <a:bodyPr/>
+          <a:lstStyle>
+            <a:lvl1pPr>
+              <a:defRPr>
+                <a:solidFill>
+                  <a:schemeClr val="bg1"/>
+                </a:solidFill>
+              </a:defRPr>
+            </a:lvl1pPr>
+          </a:lstStyle>
+          <a:p>
+            <a:fld id="{D8E684C7-7750-4CD9-985D-E80E6D7E3A96}" type="slidenum">
+              <a:rPr lang="en-AU" smtClean="0"/>
+              <a:pPr/>
+              <a:t>‹#›</a:t>
+            </a:fld>
+            <a:endParaRPr lang="en-AU" dirty="0"/>
+          </a:p>
+        </p:txBody>
+      </p:sp>
+      <p:sp>
+        <p:nvSpPr>
+          <p:cNvPr id="2" name="Title 1">
+            <a:extLst>
+              <a:ext uri="{FF2B5EF4-FFF2-40B4-BE49-F238E27FC236}">
+                <a16:creationId xmlns:a16="http://schemas.microsoft.com/office/drawing/2014/main" id="{384BE03C-E11F-C588-E1F8-FA5D738237EE}"/>
+              </a:ext>
+            </a:extLst>
+          </p:cNvPr>
+          <p:cNvSpPr>
+            <a:spLocks noGrp="1"/>
+          </p:cNvSpPr>
+          <p:nvPr>
+            <p:ph type="title"/>
+          </p:nvPr>
+        </p:nvSpPr>
+        <p:spPr/>
+        <p:txBody>
+          <a:bodyPr/>
+          <a:lstStyle/>
+          <a:p>
+            <a:r>
+              <a:rPr lang="en-US"/>
+              <a:t>Click to edit Master title style</a:t>
+            </a:r>
+            <a:endParaRPr lang="en-AU"/>
+          </a:p>
+        </p:txBody>
+      </p:sp>
+    </p:spTree>
+    <p:extLst>
+      <p:ext uri="{BB962C8B-B14F-4D97-AF65-F5344CB8AC3E}">
+        <p14:creationId xmlns:p14="http://schemas.microsoft.com/office/powerpoint/2010/main" val="2788376368"/>
+      </p:ext>
+    </p:extLst>
+  </p:cSld>
+  <p:clrMapOvr>
+    <a:masterClrMapping/>
+  </p:clrMapOvr>
+</p:sldLayout>
+</file>
+
+<file path=ppt/slideLayouts/slideLayout7.xml><?xml version="1.0" encoding="utf-8"?>
 <p:sldLayout xmlns:a="http://schemas.openxmlformats.org/drawingml/2006/main" xmlns:r="http://schemas.openxmlformats.org/officeDocument/2006/relationships" xmlns:p="http://schemas.openxmlformats.org/presentationml/2006/main" type="blank" preserve="1">
   <p:cSld name="Blank">
     <p:spTree>
@@ -2136,7 +2794,7 @@
 </p:sldLayout>
 </file>
 
-<file path=ppt/slideLayouts/slideLayout6.xml><?xml version="1.0" encoding="utf-8"?>
+<file path=ppt/slideLayouts/slideLayout8.xml><?xml version="1.0" encoding="utf-8"?>
 <p:sldLayout xmlns:a="http://schemas.openxmlformats.org/drawingml/2006/main" xmlns:r="http://schemas.openxmlformats.org/officeDocument/2006/relationships" xmlns:p="http://schemas.openxmlformats.org/presentationml/2006/main" type="objTx" preserve="1">
   <p:cSld name="Content with Caption">
     <p:spTree>
@@ -2850,9 +3508,11 @@
     <p:sldLayoutId id="2147483649" r:id="rId1"/>
     <p:sldLayoutId id="2147483650" r:id="rId2"/>
     <p:sldLayoutId id="2147483652" r:id="rId3"/>
-    <p:sldLayoutId id="2147483654" r:id="rId4"/>
-    <p:sldLayoutId id="2147483655" r:id="rId5"/>
-    <p:sldLayoutId id="2147483656" r:id="rId6"/>
+    <p:sldLayoutId id="2147483658" r:id="rId4"/>
+    <p:sldLayoutId id="2147483654" r:id="rId5"/>
+    <p:sldLayoutId id="2147483657" r:id="rId6"/>
+    <p:sldLayoutId id="2147483655" r:id="rId7"/>
+    <p:sldLayoutId id="2147483656" r:id="rId8"/>
   </p:sldLayoutIdLst>
   <p:hf hdr="0"/>
   <p:txStyles>

</xml_diff>

<commit_message>
update MS Office template logo blocks
</commit_message>
<xml_diff>
--- a/_extensions/aagi/pptx/template.pptx
+++ b/_extensions/aagi/pptx/template.pptx
@@ -198,7 +198,7 @@
           <a:p>
             <a:fld id="{0FAF8F18-604A-4237-961E-CD67640E1CD4}" type="datetimeFigureOut">
               <a:rPr lang="en-AU" smtClean="0"/>
-              <a:t>27/3/2026</a:t>
+              <a:t>4/5/2026</a:t>
             </a:fld>
             <a:endParaRPr lang="en-AU"/>
           </a:p>
@@ -540,8 +540,8 @@
         </p:blipFill>
         <p:spPr>
           <a:xfrm>
-            <a:off x="1422659" y="5807075"/>
-            <a:ext cx="9346681" cy="784225"/>
+            <a:off x="1422659" y="6004465"/>
+            <a:ext cx="9346681" cy="389445"/>
           </a:xfrm>
           <a:prstGeom prst="rect">
             <a:avLst/>

</xml_diff>